<commit_message>
update kethua java week6
</commit_message>
<xml_diff>
--- a/Java_Week6.pptx
+++ b/Java_Week6.pptx
@@ -1271,7 +1271,7 @@
             </a:extLst>
           </p:cNvPr>
           <p:cNvSpPr>
-            <a:spLocks noRot="1" noChangeAspect="1" noChangeArrowheads="1" noTextEdit="1"/>
+            <a:spLocks noGrp="1" noRot="1" noChangeAspect="1" noChangeArrowheads="1" noTextEdit="1"/>
           </p:cNvSpPr>
           <p:nvPr>
             <p:ph type="sldImg"/>
@@ -1506,7 +1506,7 @@
             </a:extLst>
           </p:cNvPr>
           <p:cNvSpPr>
-            <a:spLocks noRot="1" noChangeAspect="1" noChangeArrowheads="1" noTextEdit="1"/>
+            <a:spLocks noGrp="1" noRot="1" noChangeAspect="1" noChangeArrowheads="1" noTextEdit="1"/>
           </p:cNvSpPr>
           <p:nvPr>
             <p:ph type="sldImg"/>
@@ -2397,7 +2397,7 @@
             </a:extLst>
           </p:cNvPr>
           <p:cNvSpPr>
-            <a:spLocks noRot="1" noChangeAspect="1" noChangeArrowheads="1" noTextEdit="1"/>
+            <a:spLocks noGrp="1" noRot="1" noChangeAspect="1" noChangeArrowheads="1" noTextEdit="1"/>
           </p:cNvSpPr>
           <p:nvPr>
             <p:ph type="sldImg"/>
@@ -5666,7 +5666,7 @@
             </a:extLst>
           </p:cNvPr>
           <p:cNvSpPr>
-            <a:spLocks noRot="1" noChangeAspect="1" noChangeArrowheads="1" noTextEdit="1"/>
+            <a:spLocks noGrp="1" noRot="1" noChangeAspect="1" noChangeArrowheads="1" noTextEdit="1"/>
           </p:cNvSpPr>
           <p:nvPr>
             <p:ph type="sldImg"/>
@@ -6179,7 +6179,7 @@
             </a:extLst>
           </p:cNvPr>
           <p:cNvSpPr>
-            <a:spLocks noRot="1" noChangeAspect="1" noChangeArrowheads="1" noTextEdit="1"/>
+            <a:spLocks noGrp="1" noRot="1" noChangeAspect="1" noChangeArrowheads="1" noTextEdit="1"/>
           </p:cNvSpPr>
           <p:nvPr>
             <p:ph type="sldImg"/>
@@ -6816,7 +6816,7 @@
             </a:extLst>
           </p:cNvPr>
           <p:cNvSpPr>
-            <a:spLocks noRot="1" noChangeAspect="1" noChangeArrowheads="1" noTextEdit="1"/>
+            <a:spLocks noGrp="1" noRot="1" noChangeAspect="1" noChangeArrowheads="1" noTextEdit="1"/>
           </p:cNvSpPr>
           <p:nvPr>
             <p:ph type="sldImg"/>
@@ -7666,7 +7666,7 @@
             </a:extLst>
           </p:cNvPr>
           <p:cNvSpPr>
-            <a:spLocks noRot="1" noChangeAspect="1" noChangeArrowheads="1" noTextEdit="1"/>
+            <a:spLocks noGrp="1" noRot="1" noChangeAspect="1" noChangeArrowheads="1" noTextEdit="1"/>
           </p:cNvSpPr>
           <p:nvPr>
             <p:ph type="sldImg"/>
@@ -8625,7 +8625,7 @@
             </a:extLst>
           </p:cNvPr>
           <p:cNvSpPr>
-            <a:spLocks noRot="1" noChangeAspect="1" noChangeArrowheads="1" noTextEdit="1"/>
+            <a:spLocks noGrp="1" noRot="1" noChangeAspect="1" noChangeArrowheads="1" noTextEdit="1"/>
           </p:cNvSpPr>
           <p:nvPr>
             <p:ph type="sldImg"/>
@@ -9706,7 +9706,7 @@
             </a:extLst>
           </p:cNvPr>
           <p:cNvSpPr>
-            <a:spLocks noRot="1" noChangeAspect="1" noChangeArrowheads="1" noTextEdit="1"/>
+            <a:spLocks noGrp="1" noRot="1" noChangeAspect="1" noChangeArrowheads="1" noTextEdit="1"/>
           </p:cNvSpPr>
           <p:nvPr>
             <p:ph type="sldImg"/>
@@ -11290,7 +11290,7 @@
             </a:extLst>
           </p:cNvPr>
           <p:cNvSpPr>
-            <a:spLocks noRot="1" noChangeAspect="1" noChangeArrowheads="1" noTextEdit="1"/>
+            <a:spLocks noGrp="1" noRot="1" noChangeAspect="1" noChangeArrowheads="1" noTextEdit="1"/>
           </p:cNvSpPr>
           <p:nvPr>
             <p:ph type="sldImg"/>
@@ -18019,547 +18019,6 @@
       </p:sp>
       <p:sp>
         <p:nvSpPr>
-          <p:cNvPr id="7" name="Content Placeholder 6">
-            <a:extLst>
-              <a:ext uri="{FF2B5EF4-FFF2-40B4-BE49-F238E27FC236}">
-                <a16:creationId xmlns:a16="http://schemas.microsoft.com/office/drawing/2014/main" id="{B0C80D64-D1E8-8F2B-1DB8-BB0ECBEEF378}"/>
-              </a:ext>
-            </a:extLst>
-          </p:cNvPr>
-          <p:cNvSpPr>
-            <a:spLocks noGrp="1"/>
-          </p:cNvSpPr>
-          <p:nvPr>
-            <p:ph idx="1"/>
-          </p:nvPr>
-        </p:nvSpPr>
-        <p:spPr>
-          <a:xfrm>
-            <a:off x="128464" y="990600"/>
-            <a:ext cx="9649072" cy="5462736"/>
-          </a:xfrm>
-        </p:spPr>
-        <p:txBody>
-          <a:bodyPr>
-            <a:normAutofit fontScale="85000" lnSpcReduction="20000"/>
-          </a:bodyPr>
-          <a:lstStyle/>
-          <a:p>
-            <a:endParaRPr lang="en-US" altLang="ja-JP" dirty="0"/>
-          </a:p>
-          <a:p>
-            <a:pPr marL="0" indent="0">
-              <a:buNone/>
-            </a:pPr>
-            <a:r>
-              <a:rPr lang="en-US" altLang="ja-JP" dirty="0"/>
-              <a:t>【Override】</a:t>
-            </a:r>
-          </a:p>
-          <a:p>
-            <a:r>
-              <a:rPr lang="ja-JP" altLang="en-US" dirty="0"/>
-              <a:t>　</a:t>
-            </a:r>
-            <a:r>
-              <a:rPr lang="en-US" altLang="ja-JP" dirty="0"/>
-              <a:t>Là ở sub class </a:t>
-            </a:r>
-            <a:r>
-              <a:rPr lang="en-US" altLang="ja-JP" dirty="0" err="1"/>
-              <a:t>định</a:t>
-            </a:r>
-            <a:r>
-              <a:rPr lang="en-US" altLang="ja-JP" dirty="0"/>
-              <a:t> </a:t>
-            </a:r>
-            <a:r>
-              <a:rPr lang="en-US" altLang="ja-JP" dirty="0" err="1"/>
-              <a:t>nghĩa</a:t>
-            </a:r>
-            <a:r>
-              <a:rPr lang="en-US" altLang="ja-JP" dirty="0"/>
-              <a:t> method </a:t>
-            </a:r>
-            <a:r>
-              <a:rPr lang="en-US" altLang="ja-JP" dirty="0" err="1"/>
-              <a:t>của</a:t>
-            </a:r>
-            <a:r>
-              <a:rPr lang="en-US" altLang="ja-JP" dirty="0"/>
-              <a:t> supper class </a:t>
-            </a:r>
-            <a:r>
-              <a:rPr lang="en-US" altLang="ja-JP" dirty="0" err="1"/>
-              <a:t>va</a:t>
-            </a:r>
-            <a:r>
-              <a:rPr lang="en-US" altLang="ja-JP" dirty="0"/>
-              <a:t>̀ method </a:t>
-            </a:r>
-            <a:r>
-              <a:rPr lang="en-US" altLang="ja-JP" dirty="0" err="1"/>
-              <a:t>có</a:t>
-            </a:r>
-            <a:r>
-              <a:rPr lang="en-US" altLang="ja-JP" dirty="0"/>
-              <a:t> </a:t>
-            </a:r>
-            <a:r>
-              <a:rPr lang="en-US" altLang="ja-JP" dirty="0">
-                <a:ea typeface="MS UI Gothic" panose="020B0600070205080204" pitchFamily="50" charset="-128"/>
-              </a:rPr>
-              <a:t>signature (name </a:t>
-            </a:r>
-            <a:r>
-              <a:rPr lang="en-US" altLang="ja-JP" dirty="0" err="1">
-                <a:ea typeface="MS UI Gothic" panose="020B0600070205080204" pitchFamily="50" charset="-128"/>
-              </a:rPr>
-              <a:t>va</a:t>
-            </a:r>
-            <a:r>
-              <a:rPr lang="en-US" altLang="ja-JP" dirty="0">
-                <a:ea typeface="MS UI Gothic" panose="020B0600070205080204" pitchFamily="50" charset="-128"/>
-              </a:rPr>
-              <a:t>̀ list </a:t>
-            </a:r>
-            <a:r>
-              <a:rPr lang="en-US" altLang="ja-JP" dirty="0" err="1">
-                <a:ea typeface="MS UI Gothic" panose="020B0600070205080204" pitchFamily="50" charset="-128"/>
-              </a:rPr>
-              <a:t>đối</a:t>
-            </a:r>
-            <a:r>
-              <a:rPr lang="en-US" altLang="ja-JP" dirty="0">
-                <a:ea typeface="MS UI Gothic" panose="020B0600070205080204" pitchFamily="50" charset="-128"/>
-              </a:rPr>
-              <a:t> </a:t>
-            </a:r>
-            <a:r>
-              <a:rPr lang="en-US" altLang="ja-JP" dirty="0" err="1">
-                <a:ea typeface="MS UI Gothic" panose="020B0600070205080204" pitchFamily="50" charset="-128"/>
-              </a:rPr>
-              <a:t>sô</a:t>
-            </a:r>
-            <a:r>
-              <a:rPr lang="en-US" altLang="ja-JP" dirty="0">
-                <a:ea typeface="MS UI Gothic" panose="020B0600070205080204" pitchFamily="50" charset="-128"/>
-              </a:rPr>
-              <a:t>́) </a:t>
-            </a:r>
-            <a:r>
-              <a:rPr lang="en-US" altLang="ja-JP" dirty="0" err="1">
-                <a:ea typeface="MS UI Gothic" panose="020B0600070205080204" pitchFamily="50" charset="-128"/>
-              </a:rPr>
-              <a:t>hoàn</a:t>
-            </a:r>
-            <a:r>
-              <a:rPr lang="en-US" altLang="ja-JP" dirty="0">
-                <a:ea typeface="MS UI Gothic" panose="020B0600070205080204" pitchFamily="50" charset="-128"/>
-              </a:rPr>
-              <a:t> </a:t>
-            </a:r>
-            <a:r>
-              <a:rPr lang="en-US" altLang="ja-JP" dirty="0" err="1">
-                <a:ea typeface="MS UI Gothic" panose="020B0600070205080204" pitchFamily="50" charset="-128"/>
-              </a:rPr>
-              <a:t>toàn</a:t>
-            </a:r>
-            <a:r>
-              <a:rPr lang="en-US" altLang="ja-JP" dirty="0">
-                <a:ea typeface="MS UI Gothic" panose="020B0600070205080204" pitchFamily="50" charset="-128"/>
-              </a:rPr>
-              <a:t> </a:t>
-            </a:r>
-            <a:r>
-              <a:rPr lang="en-US" altLang="ja-JP" dirty="0" err="1">
-                <a:ea typeface="MS UI Gothic" panose="020B0600070205080204" pitchFamily="50" charset="-128"/>
-              </a:rPr>
-              <a:t>giống</a:t>
-            </a:r>
-            <a:r>
-              <a:rPr lang="en-US" altLang="ja-JP" dirty="0">
-                <a:ea typeface="MS UI Gothic" panose="020B0600070205080204" pitchFamily="50" charset="-128"/>
-              </a:rPr>
-              <a:t> </a:t>
-            </a:r>
-            <a:r>
-              <a:rPr lang="en-US" altLang="ja-JP" dirty="0" err="1">
-                <a:ea typeface="MS UI Gothic" panose="020B0600070205080204" pitchFamily="50" charset="-128"/>
-              </a:rPr>
-              <a:t>nhau</a:t>
-            </a:r>
-            <a:endParaRPr lang="en-US" altLang="ja-JP" dirty="0"/>
-          </a:p>
-          <a:p>
-            <a:r>
-              <a:rPr lang="ja-JP" altLang="en-US" dirty="0"/>
-              <a:t>　（</a:t>
-            </a:r>
-            <a:r>
-              <a:rPr lang="en-US" altLang="ja-JP" dirty="0" err="1"/>
-              <a:t>Vê</a:t>
-            </a:r>
-            <a:r>
-              <a:rPr lang="en-US" altLang="ja-JP" dirty="0"/>
-              <a:t>̀ </a:t>
-            </a:r>
-            <a:r>
-              <a:rPr lang="en-US" altLang="ja-JP" dirty="0" err="1"/>
-              <a:t>tính</a:t>
-            </a:r>
-            <a:r>
-              <a:rPr lang="en-US" altLang="ja-JP" dirty="0"/>
-              <a:t> </a:t>
-            </a:r>
-            <a:r>
-              <a:rPr lang="en-US" altLang="ja-JP" dirty="0" err="1"/>
-              <a:t>năng</a:t>
-            </a:r>
-            <a:r>
-              <a:rPr lang="en-US" altLang="ja-JP" dirty="0"/>
-              <a:t> superclass </a:t>
-            </a:r>
-            <a:r>
-              <a:rPr lang="en-US" altLang="ja-JP" dirty="0" err="1"/>
-              <a:t>đang</a:t>
-            </a:r>
-            <a:r>
-              <a:rPr lang="en-US" altLang="ja-JP" dirty="0"/>
-              <a:t> </a:t>
-            </a:r>
-            <a:r>
-              <a:rPr lang="en-US" altLang="ja-JP" dirty="0" err="1"/>
-              <a:t>có</a:t>
-            </a:r>
-            <a:r>
-              <a:rPr lang="en-US" altLang="ja-JP" dirty="0"/>
-              <a:t>, sẽ </a:t>
-            </a:r>
-            <a:r>
-              <a:rPr lang="en-US" altLang="ja-JP" dirty="0" err="1"/>
-              <a:t>định</a:t>
-            </a:r>
-            <a:r>
-              <a:rPr lang="en-US" altLang="ja-JP" dirty="0"/>
-              <a:t> </a:t>
-            </a:r>
-            <a:r>
-              <a:rPr lang="en-US" altLang="ja-JP" dirty="0" err="1"/>
-              <a:t>nghĩa</a:t>
-            </a:r>
-            <a:r>
-              <a:rPr lang="en-US" altLang="ja-JP" dirty="0"/>
-              <a:t> </a:t>
-            </a:r>
-            <a:r>
-              <a:rPr lang="en-US" altLang="ja-JP" dirty="0" err="1"/>
-              <a:t>lại</a:t>
-            </a:r>
-            <a:r>
-              <a:rPr lang="en-US" altLang="ja-JP" dirty="0"/>
-              <a:t> </a:t>
-            </a:r>
-            <a:r>
-              <a:rPr lang="en-US" altLang="ja-JP" dirty="0" err="1"/>
-              <a:t>một</a:t>
-            </a:r>
-            <a:r>
-              <a:rPr lang="en-US" altLang="ja-JP" dirty="0"/>
-              <a:t> </a:t>
-            </a:r>
-            <a:r>
-              <a:rPr lang="en-US" altLang="ja-JP" dirty="0" err="1"/>
-              <a:t>cách</a:t>
-            </a:r>
-            <a:r>
-              <a:rPr lang="en-US" altLang="ja-JP" dirty="0"/>
-              <a:t> </a:t>
-            </a:r>
-            <a:r>
-              <a:rPr lang="en-US" altLang="ja-JP" dirty="0" err="1"/>
-              <a:t>độc</a:t>
-            </a:r>
-            <a:r>
-              <a:rPr lang="en-US" altLang="ja-JP" dirty="0"/>
-              <a:t> </a:t>
-            </a:r>
-            <a:r>
-              <a:rPr lang="en-US" altLang="ja-JP" dirty="0" err="1"/>
-              <a:t>lập</a:t>
-            </a:r>
-            <a:r>
-              <a:rPr lang="en-US" altLang="ja-JP" dirty="0"/>
-              <a:t> ở </a:t>
-            </a:r>
-            <a:r>
-              <a:rPr lang="en-US" altLang="ja-JP" dirty="0" err="1"/>
-              <a:t>phía</a:t>
-            </a:r>
-            <a:r>
-              <a:rPr lang="en-US" altLang="ja-JP" dirty="0"/>
-              <a:t> subclass</a:t>
-            </a:r>
-            <a:r>
-              <a:rPr lang="ja-JP" altLang="en-US" dirty="0"/>
-              <a:t>）</a:t>
-            </a:r>
-          </a:p>
-          <a:p>
-            <a:endParaRPr lang="ja-JP" altLang="en-US" dirty="0"/>
-          </a:p>
-          <a:p>
-            <a:pPr marL="0" indent="0">
-              <a:buNone/>
-            </a:pPr>
-            <a:r>
-              <a:rPr lang="en-US" altLang="ja-JP" dirty="0"/>
-              <a:t>【Overload】</a:t>
-            </a:r>
-          </a:p>
-          <a:p>
-            <a:r>
-              <a:rPr lang="ja-JP" altLang="en-US" dirty="0"/>
-              <a:t>　</a:t>
-            </a:r>
-            <a:r>
-              <a:rPr lang="en-US" altLang="ja-JP" dirty="0"/>
-              <a:t>Là </a:t>
-            </a:r>
-            <a:r>
-              <a:rPr lang="en-US" altLang="ja-JP" dirty="0" err="1"/>
-              <a:t>định</a:t>
-            </a:r>
-            <a:r>
-              <a:rPr lang="en-US" altLang="ja-JP" dirty="0"/>
-              <a:t> </a:t>
-            </a:r>
-            <a:r>
-              <a:rPr lang="en-US" altLang="ja-JP" dirty="0" err="1"/>
-              <a:t>nghĩa</a:t>
-            </a:r>
-            <a:r>
-              <a:rPr lang="en-US" altLang="ja-JP" dirty="0"/>
-              <a:t> </a:t>
-            </a:r>
-            <a:r>
-              <a:rPr lang="en-US" altLang="ja-JP" dirty="0" err="1"/>
-              <a:t>nhiều</a:t>
-            </a:r>
-            <a:r>
-              <a:rPr lang="en-US" altLang="ja-JP" dirty="0"/>
-              <a:t> method/ constructor có name </a:t>
-            </a:r>
-            <a:r>
-              <a:rPr lang="en-US" altLang="ja-JP" dirty="0" err="1"/>
-              <a:t>giống</a:t>
-            </a:r>
-            <a:r>
-              <a:rPr lang="en-US" altLang="ja-JP" dirty="0"/>
-              <a:t> </a:t>
-            </a:r>
-            <a:r>
-              <a:rPr lang="en-US" altLang="ja-JP" dirty="0" err="1"/>
-              <a:t>nhau</a:t>
-            </a:r>
-            <a:r>
-              <a:rPr lang="en-US" altLang="ja-JP" dirty="0"/>
-              <a:t>  </a:t>
-            </a:r>
-            <a:r>
-              <a:rPr lang="en-US" altLang="ja-JP" dirty="0" err="1"/>
-              <a:t>nhưng</a:t>
-            </a:r>
-            <a:r>
-              <a:rPr lang="en-US" altLang="ja-JP" dirty="0"/>
-              <a:t> </a:t>
-            </a:r>
-            <a:r>
-              <a:rPr lang="en-US" altLang="ja-JP" dirty="0" err="1"/>
-              <a:t>đối</a:t>
-            </a:r>
-            <a:r>
-              <a:rPr lang="en-US" altLang="ja-JP" dirty="0"/>
-              <a:t> </a:t>
-            </a:r>
-            <a:r>
-              <a:rPr lang="en-US" altLang="ja-JP" dirty="0" err="1"/>
-              <a:t>sô</a:t>
-            </a:r>
-            <a:r>
-              <a:rPr lang="en-US" altLang="ja-JP" dirty="0"/>
-              <a:t>́ </a:t>
-            </a:r>
-            <a:r>
-              <a:rPr lang="en-US" altLang="ja-JP" dirty="0" err="1"/>
-              <a:t>khác</a:t>
-            </a:r>
-            <a:r>
-              <a:rPr lang="en-US" altLang="ja-JP" dirty="0"/>
-              <a:t> </a:t>
-            </a:r>
-            <a:r>
-              <a:rPr lang="en-US" altLang="ja-JP" dirty="0" err="1"/>
-              <a:t>nhau</a:t>
-            </a:r>
-            <a:r>
-              <a:rPr lang="en-US" altLang="ja-JP" dirty="0"/>
-              <a:t> </a:t>
-            </a:r>
-            <a:r>
-              <a:rPr lang="en-US" altLang="ja-JP" dirty="0" err="1"/>
-              <a:t>trong</a:t>
-            </a:r>
-            <a:r>
-              <a:rPr lang="en-US" altLang="ja-JP" dirty="0"/>
-              <a:t> </a:t>
-            </a:r>
-            <a:r>
-              <a:rPr lang="en-US" altLang="ja-JP" dirty="0" err="1"/>
-              <a:t>cùng</a:t>
-            </a:r>
-            <a:r>
-              <a:rPr lang="en-US" altLang="ja-JP" dirty="0"/>
-              <a:t> 1 class.</a:t>
-            </a:r>
-          </a:p>
-          <a:p>
-            <a:r>
-              <a:rPr lang="en-US" altLang="ja-JP" dirty="0"/>
-              <a:t> </a:t>
-            </a:r>
-            <a:r>
-              <a:rPr lang="ja-JP" altLang="en-US" dirty="0"/>
-              <a:t>　（</a:t>
-            </a:r>
-            <a:r>
-              <a:rPr lang="en-US" altLang="ja-JP" dirty="0"/>
-              <a:t>Trường </a:t>
-            </a:r>
-            <a:r>
-              <a:rPr lang="en-US" altLang="ja-JP" dirty="0" err="1"/>
-              <a:t>hợp</a:t>
-            </a:r>
-            <a:r>
-              <a:rPr lang="en-US" altLang="ja-JP" dirty="0"/>
-              <a:t> </a:t>
-            </a:r>
-            <a:r>
-              <a:rPr lang="en-US" altLang="ja-JP" dirty="0" err="1"/>
-              <a:t>muốn</a:t>
-            </a:r>
-            <a:r>
-              <a:rPr lang="en-US" altLang="ja-JP" dirty="0"/>
-              <a:t> </a:t>
-            </a:r>
-            <a:r>
-              <a:rPr lang="en-US" altLang="ja-JP" dirty="0" err="1"/>
-              <a:t>định</a:t>
-            </a:r>
-            <a:r>
-              <a:rPr lang="en-US" altLang="ja-JP" dirty="0"/>
-              <a:t> </a:t>
-            </a:r>
-            <a:r>
-              <a:rPr lang="en-US" altLang="ja-JP" dirty="0" err="1"/>
-              <a:t>nghĩa</a:t>
-            </a:r>
-            <a:r>
-              <a:rPr lang="en-US" altLang="ja-JP" dirty="0"/>
-              <a:t> </a:t>
-            </a:r>
-            <a:r>
-              <a:rPr lang="en-US" altLang="ja-JP" dirty="0" err="1"/>
-              <a:t>chức</a:t>
-            </a:r>
-            <a:r>
-              <a:rPr lang="en-US" altLang="ja-JP" dirty="0"/>
-              <a:t> </a:t>
-            </a:r>
-            <a:r>
-              <a:rPr lang="en-US" altLang="ja-JP" dirty="0" err="1"/>
-              <a:t>năng</a:t>
-            </a:r>
-            <a:r>
-              <a:rPr lang="en-US" altLang="ja-JP" dirty="0"/>
-              <a:t> </a:t>
-            </a:r>
-            <a:r>
-              <a:rPr lang="en-US" altLang="ja-JP" dirty="0" err="1"/>
-              <a:t>nào</a:t>
-            </a:r>
-            <a:r>
-              <a:rPr lang="en-US" altLang="ja-JP" dirty="0"/>
-              <a:t> </a:t>
-            </a:r>
-            <a:r>
-              <a:rPr lang="en-US" altLang="ja-JP" dirty="0" err="1"/>
-              <a:t>đo</a:t>
-            </a:r>
-            <a:r>
-              <a:rPr lang="en-US" altLang="ja-JP" dirty="0"/>
-              <a:t>́ </a:t>
-            </a:r>
-            <a:r>
-              <a:rPr lang="en-US" altLang="ja-JP" dirty="0" err="1"/>
-              <a:t>nhưng</a:t>
-            </a:r>
-            <a:r>
-              <a:rPr lang="en-US" altLang="ja-JP" dirty="0"/>
-              <a:t> </a:t>
-            </a:r>
-            <a:r>
-              <a:rPr lang="en-US" altLang="ja-JP" dirty="0" err="1"/>
-              <a:t>tồn</a:t>
-            </a:r>
-            <a:r>
-              <a:rPr lang="en-US" altLang="ja-JP" dirty="0"/>
-              <a:t> </a:t>
-            </a:r>
-            <a:r>
-              <a:rPr lang="en-US" altLang="ja-JP" dirty="0" err="1"/>
-              <a:t>tại</a:t>
-            </a:r>
-            <a:r>
-              <a:rPr lang="en-US" altLang="ja-JP" dirty="0"/>
-              <a:t> </a:t>
-            </a:r>
-            <a:r>
-              <a:rPr lang="en-US" altLang="ja-JP" dirty="0" err="1"/>
-              <a:t>nhiều</a:t>
-            </a:r>
-            <a:r>
-              <a:rPr lang="en-US" altLang="ja-JP" dirty="0"/>
-              <a:t> pattern </a:t>
-            </a:r>
-            <a:r>
-              <a:rPr lang="en-US" altLang="ja-JP" dirty="0" err="1"/>
-              <a:t>đối</a:t>
-            </a:r>
-            <a:r>
-              <a:rPr lang="en-US" altLang="ja-JP" dirty="0"/>
-              <a:t> </a:t>
-            </a:r>
-            <a:r>
-              <a:rPr lang="en-US" altLang="ja-JP" dirty="0" err="1"/>
-              <a:t>sô</a:t>
-            </a:r>
-            <a:r>
-              <a:rPr lang="en-US" altLang="ja-JP" dirty="0"/>
-              <a:t>́ </a:t>
-            </a:r>
-            <a:r>
-              <a:rPr lang="ja-JP" altLang="en-US" dirty="0"/>
-              <a:t>）</a:t>
-            </a:r>
-          </a:p>
-          <a:p>
-            <a:endParaRPr lang="ja-JP" altLang="en-US" dirty="0"/>
-          </a:p>
-        </p:txBody>
-      </p:sp>
-      <p:sp>
-        <p:nvSpPr>
           <p:cNvPr id="5" name="Slide Number Placeholder 4">
             <a:extLst>
               <a:ext uri="{FF2B5EF4-FFF2-40B4-BE49-F238E27FC236}">
@@ -18588,6 +18047,681 @@
           </a:p>
         </p:txBody>
       </p:sp>
+      <p:graphicFrame>
+        <p:nvGraphicFramePr>
+          <p:cNvPr id="2" name="Table 1">
+            <a:extLst>
+              <a:ext uri="{FF2B5EF4-FFF2-40B4-BE49-F238E27FC236}">
+                <a16:creationId xmlns:a16="http://schemas.microsoft.com/office/drawing/2014/main" id="{0BEE7186-B2BC-8B16-7EFC-0E3A00C49D64}"/>
+              </a:ext>
+            </a:extLst>
+          </p:cNvPr>
+          <p:cNvGraphicFramePr>
+            <a:graphicFrameLocks noGrp="1"/>
+          </p:cNvGraphicFramePr>
+          <p:nvPr>
+            <p:extLst>
+              <p:ext uri="{D42A27DB-BD31-4B8C-83A1-F6EECF244321}">
+                <p14:modId xmlns:p14="http://schemas.microsoft.com/office/powerpoint/2010/main" val="383963497"/>
+              </p:ext>
+            </p:extLst>
+          </p:nvPr>
+        </p:nvGraphicFramePr>
+        <p:xfrm>
+          <a:off x="457200" y="1295400"/>
+          <a:ext cx="9146382" cy="4495800"/>
+        </p:xfrm>
+        <a:graphic>
+          <a:graphicData uri="http://schemas.openxmlformats.org/drawingml/2006/table">
+            <a:tbl>
+              <a:tblPr>
+                <a:tableStyleId>{BDBED569-4797-4DF1-A0F4-6AAB3CD982D8}</a:tableStyleId>
+              </a:tblPr>
+              <a:tblGrid>
+                <a:gridCol w="3048794">
+                  <a:extLst>
+                    <a:ext uri="{9D8B030D-6E8A-4147-A177-3AD203B41FA5}">
+                      <a16:colId xmlns:a16="http://schemas.microsoft.com/office/drawing/2014/main" val="3133295790"/>
+                    </a:ext>
+                  </a:extLst>
+                </a:gridCol>
+                <a:gridCol w="3048794">
+                  <a:extLst>
+                    <a:ext uri="{9D8B030D-6E8A-4147-A177-3AD203B41FA5}">
+                      <a16:colId xmlns:a16="http://schemas.microsoft.com/office/drawing/2014/main" val="660928648"/>
+                    </a:ext>
+                  </a:extLst>
+                </a:gridCol>
+                <a:gridCol w="3048794">
+                  <a:extLst>
+                    <a:ext uri="{9D8B030D-6E8A-4147-A177-3AD203B41FA5}">
+                      <a16:colId xmlns:a16="http://schemas.microsoft.com/office/drawing/2014/main" val="1809643327"/>
+                    </a:ext>
+                  </a:extLst>
+                </a:gridCol>
+              </a:tblGrid>
+              <a:tr h="749300">
+                <a:tc>
+                  <a:txBody>
+                    <a:bodyPr/>
+                    <a:lstStyle/>
+                    <a:p>
+                      <a:pPr>
+                        <a:lnSpc>
+                          <a:spcPct val="115000"/>
+                        </a:lnSpc>
+                        <a:buNone/>
+                      </a:pPr>
+                      <a:r>
+                        <a:rPr lang="ja-JP" sz="2000" kern="100">
+                          <a:effectLst/>
+                          <a:highlight>
+                            <a:srgbClr val="FFFFFF"/>
+                          </a:highlight>
+                        </a:rPr>
+                        <a:t>Tiêu chí</a:t>
+                      </a:r>
+                      <a:endParaRPr lang="ja-JP" sz="1800" kern="100">
+                        <a:effectLst/>
+                        <a:highlight>
+                          <a:srgbClr val="FFFFFF"/>
+                        </a:highlight>
+                        <a:latin typeface="+mj-lt"/>
+                        <a:ea typeface="游明朝" panose="02020400000000000000" pitchFamily="18" charset="-128"/>
+                      </a:endParaRPr>
+                    </a:p>
+                  </a:txBody>
+                  <a:tcPr marL="68580" marR="68580" marT="0" marB="0"/>
+                </a:tc>
+                <a:tc>
+                  <a:txBody>
+                    <a:bodyPr/>
+                    <a:lstStyle/>
+                    <a:p>
+                      <a:pPr>
+                        <a:lnSpc>
+                          <a:spcPct val="115000"/>
+                        </a:lnSpc>
+                        <a:buNone/>
+                      </a:pPr>
+                      <a:r>
+                        <a:rPr lang="ja-JP" sz="2000" kern="100">
+                          <a:effectLst/>
+                          <a:highlight>
+                            <a:srgbClr val="FFFFFF"/>
+                          </a:highlight>
+                        </a:rPr>
+                        <a:t>Overloading</a:t>
+                      </a:r>
+                      <a:endParaRPr lang="ja-JP" sz="1800" kern="100">
+                        <a:effectLst/>
+                        <a:highlight>
+                          <a:srgbClr val="FFFFFF"/>
+                        </a:highlight>
+                        <a:latin typeface="+mj-lt"/>
+                        <a:ea typeface="游明朝" panose="02020400000000000000" pitchFamily="18" charset="-128"/>
+                      </a:endParaRPr>
+                    </a:p>
+                  </a:txBody>
+                  <a:tcPr marL="68580" marR="68580" marT="0" marB="0"/>
+                </a:tc>
+                <a:tc>
+                  <a:txBody>
+                    <a:bodyPr/>
+                    <a:lstStyle/>
+                    <a:p>
+                      <a:pPr algn="ctr">
+                        <a:lnSpc>
+                          <a:spcPct val="115000"/>
+                        </a:lnSpc>
+                        <a:buNone/>
+                      </a:pPr>
+                      <a:r>
+                        <a:rPr lang="ja-JP" sz="2000" kern="100" dirty="0">
+                          <a:effectLst/>
+                          <a:highlight>
+                            <a:srgbClr val="FFFFFF"/>
+                          </a:highlight>
+                        </a:rPr>
+                        <a:t>Overriding</a:t>
+                      </a:r>
+                      <a:endParaRPr lang="ja-JP" sz="1800" kern="100" dirty="0">
+                        <a:effectLst/>
+                        <a:highlight>
+                          <a:srgbClr val="FFFFFF"/>
+                        </a:highlight>
+                        <a:latin typeface="+mj-lt"/>
+                        <a:ea typeface="游明朝" panose="02020400000000000000" pitchFamily="18" charset="-128"/>
+                      </a:endParaRPr>
+                    </a:p>
+                  </a:txBody>
+                  <a:tcPr marL="68580" marR="68580" marT="0" marB="0"/>
+                </a:tc>
+                <a:extLst>
+                  <a:ext uri="{0D108BD9-81ED-4DB2-BD59-A6C34878D82A}">
+                    <a16:rowId xmlns:a16="http://schemas.microsoft.com/office/drawing/2014/main" val="3513323176"/>
+                  </a:ext>
+                </a:extLst>
+              </a:tr>
+              <a:tr h="749300">
+                <a:tc>
+                  <a:txBody>
+                    <a:bodyPr/>
+                    <a:lstStyle/>
+                    <a:p>
+                      <a:pPr>
+                        <a:lnSpc>
+                          <a:spcPct val="115000"/>
+                        </a:lnSpc>
+                        <a:buNone/>
+                      </a:pPr>
+                      <a:r>
+                        <a:rPr lang="ja-JP" sz="2000" kern="100" dirty="0">
+                          <a:effectLst/>
+                          <a:highlight>
+                            <a:srgbClr val="FFFFFF"/>
+                          </a:highlight>
+                        </a:rPr>
+                        <a:t> Xảy ra ở đâu? </a:t>
+                      </a:r>
+                      <a:endParaRPr lang="ja-JP" sz="1800" kern="100" dirty="0">
+                        <a:effectLst/>
+                        <a:highlight>
+                          <a:srgbClr val="FFFFFF"/>
+                        </a:highlight>
+                        <a:latin typeface="+mj-lt"/>
+                        <a:ea typeface="游明朝" panose="02020400000000000000" pitchFamily="18" charset="-128"/>
+                      </a:endParaRPr>
+                    </a:p>
+                  </a:txBody>
+                  <a:tcPr marL="68580" marR="68580" marT="0" marB="0"/>
+                </a:tc>
+                <a:tc>
+                  <a:txBody>
+                    <a:bodyPr/>
+                    <a:lstStyle/>
+                    <a:p>
+                      <a:pPr>
+                        <a:lnSpc>
+                          <a:spcPct val="115000"/>
+                        </a:lnSpc>
+                        <a:buNone/>
+                      </a:pPr>
+                      <a:r>
+                        <a:rPr lang="ja-JP" sz="2000" kern="100">
+                          <a:effectLst/>
+                          <a:highlight>
+                            <a:srgbClr val="FFFFFF"/>
+                          </a:highlight>
+                        </a:rPr>
+                        <a:t>Cùng một lớp</a:t>
+                      </a:r>
+                      <a:endParaRPr lang="ja-JP" sz="1800" kern="100">
+                        <a:effectLst/>
+                        <a:highlight>
+                          <a:srgbClr val="FFFFFF"/>
+                        </a:highlight>
+                        <a:latin typeface="+mj-lt"/>
+                        <a:ea typeface="游明朝" panose="02020400000000000000" pitchFamily="18" charset="-128"/>
+                      </a:endParaRPr>
+                    </a:p>
+                  </a:txBody>
+                  <a:tcPr marL="68580" marR="68580" marT="0" marB="0"/>
+                </a:tc>
+                <a:tc>
+                  <a:txBody>
+                    <a:bodyPr/>
+                    <a:lstStyle/>
+                    <a:p>
+                      <a:pPr>
+                        <a:lnSpc>
+                          <a:spcPct val="115000"/>
+                        </a:lnSpc>
+                        <a:buNone/>
+                      </a:pPr>
+                      <a:r>
+                        <a:rPr lang="ja-JP" sz="2000" kern="100">
+                          <a:effectLst/>
+                          <a:highlight>
+                            <a:srgbClr val="FFFFFF"/>
+                          </a:highlight>
+                        </a:rPr>
+                        <a:t>Giữa lớp cha và lớp con</a:t>
+                      </a:r>
+                      <a:endParaRPr lang="ja-JP" sz="1800" kern="100">
+                        <a:effectLst/>
+                        <a:highlight>
+                          <a:srgbClr val="FFFFFF"/>
+                        </a:highlight>
+                        <a:latin typeface="+mj-lt"/>
+                        <a:ea typeface="游明朝" panose="02020400000000000000" pitchFamily="18" charset="-128"/>
+                      </a:endParaRPr>
+                    </a:p>
+                  </a:txBody>
+                  <a:tcPr marL="68580" marR="68580" marT="0" marB="0"/>
+                </a:tc>
+                <a:extLst>
+                  <a:ext uri="{0D108BD9-81ED-4DB2-BD59-A6C34878D82A}">
+                    <a16:rowId xmlns:a16="http://schemas.microsoft.com/office/drawing/2014/main" val="3712001856"/>
+                  </a:ext>
+                </a:extLst>
+              </a:tr>
+              <a:tr h="749300">
+                <a:tc>
+                  <a:txBody>
+                    <a:bodyPr/>
+                    <a:lstStyle/>
+                    <a:p>
+                      <a:pPr>
+                        <a:lnSpc>
+                          <a:spcPct val="115000"/>
+                        </a:lnSpc>
+                        <a:buNone/>
+                      </a:pPr>
+                      <a:r>
+                        <a:rPr lang="ja-JP" sz="2000" kern="100" dirty="0">
+                          <a:effectLst/>
+                          <a:highlight>
+                            <a:srgbClr val="FFFFFF"/>
+                          </a:highlight>
+                        </a:rPr>
+                        <a:t>Tên phương thức</a:t>
+                      </a:r>
+                      <a:endParaRPr lang="ja-JP" sz="1800" kern="100" dirty="0">
+                        <a:effectLst/>
+                        <a:highlight>
+                          <a:srgbClr val="FFFFFF"/>
+                        </a:highlight>
+                        <a:latin typeface="+mj-lt"/>
+                        <a:ea typeface="游明朝" panose="02020400000000000000" pitchFamily="18" charset="-128"/>
+                      </a:endParaRPr>
+                    </a:p>
+                  </a:txBody>
+                  <a:tcPr marL="68580" marR="68580" marT="0" marB="0"/>
+                </a:tc>
+                <a:tc>
+                  <a:txBody>
+                    <a:bodyPr/>
+                    <a:lstStyle/>
+                    <a:p>
+                      <a:pPr>
+                        <a:lnSpc>
+                          <a:spcPct val="115000"/>
+                        </a:lnSpc>
+                        <a:buNone/>
+                      </a:pPr>
+                      <a:r>
+                        <a:rPr lang="ja-JP" sz="2000" kern="100" dirty="0">
+                          <a:effectLst/>
+                          <a:highlight>
+                            <a:srgbClr val="FFFFFF"/>
+                          </a:highlight>
+                        </a:rPr>
+                        <a:t>Giống nhau</a:t>
+                      </a:r>
+                      <a:endParaRPr lang="ja-JP" sz="1800" kern="100" dirty="0">
+                        <a:effectLst/>
+                        <a:highlight>
+                          <a:srgbClr val="FFFFFF"/>
+                        </a:highlight>
+                        <a:latin typeface="+mj-lt"/>
+                        <a:ea typeface="游明朝" panose="02020400000000000000" pitchFamily="18" charset="-128"/>
+                      </a:endParaRPr>
+                    </a:p>
+                  </a:txBody>
+                  <a:tcPr marL="68580" marR="68580" marT="0" marB="0"/>
+                </a:tc>
+                <a:tc>
+                  <a:txBody>
+                    <a:bodyPr/>
+                    <a:lstStyle/>
+                    <a:p>
+                      <a:pPr>
+                        <a:lnSpc>
+                          <a:spcPct val="115000"/>
+                        </a:lnSpc>
+                        <a:buNone/>
+                      </a:pPr>
+                      <a:r>
+                        <a:rPr lang="ja-JP" sz="2000" kern="100">
+                          <a:effectLst/>
+                          <a:highlight>
+                            <a:srgbClr val="FFFFFF"/>
+                          </a:highlight>
+                        </a:rPr>
+                        <a:t>Giống nhau</a:t>
+                      </a:r>
+                      <a:endParaRPr lang="ja-JP" sz="1800" kern="100">
+                        <a:effectLst/>
+                        <a:highlight>
+                          <a:srgbClr val="FFFFFF"/>
+                        </a:highlight>
+                        <a:latin typeface="+mj-lt"/>
+                        <a:ea typeface="游明朝" panose="02020400000000000000" pitchFamily="18" charset="-128"/>
+                      </a:endParaRPr>
+                    </a:p>
+                  </a:txBody>
+                  <a:tcPr marL="68580" marR="68580" marT="0" marB="0"/>
+                </a:tc>
+                <a:extLst>
+                  <a:ext uri="{0D108BD9-81ED-4DB2-BD59-A6C34878D82A}">
+                    <a16:rowId xmlns:a16="http://schemas.microsoft.com/office/drawing/2014/main" val="1348355471"/>
+                  </a:ext>
+                </a:extLst>
+              </a:tr>
+              <a:tr h="749300">
+                <a:tc>
+                  <a:txBody>
+                    <a:bodyPr/>
+                    <a:lstStyle/>
+                    <a:p>
+                      <a:pPr>
+                        <a:lnSpc>
+                          <a:spcPct val="115000"/>
+                        </a:lnSpc>
+                        <a:buNone/>
+                      </a:pPr>
+                      <a:r>
+                        <a:rPr lang="ja-JP" sz="2000" kern="100">
+                          <a:effectLst/>
+                          <a:highlight>
+                            <a:srgbClr val="FFFFFF"/>
+                          </a:highlight>
+                        </a:rPr>
+                        <a:t>Tham số </a:t>
+                      </a:r>
+                      <a:endParaRPr lang="ja-JP" sz="1800" kern="100">
+                        <a:effectLst/>
+                        <a:highlight>
+                          <a:srgbClr val="FFFFFF"/>
+                        </a:highlight>
+                        <a:latin typeface="+mj-lt"/>
+                        <a:ea typeface="游明朝" panose="02020400000000000000" pitchFamily="18" charset="-128"/>
+                      </a:endParaRPr>
+                    </a:p>
+                  </a:txBody>
+                  <a:tcPr marL="68580" marR="68580" marT="0" marB="0"/>
+                </a:tc>
+                <a:tc>
+                  <a:txBody>
+                    <a:bodyPr/>
+                    <a:lstStyle/>
+                    <a:p>
+                      <a:pPr>
+                        <a:lnSpc>
+                          <a:spcPct val="115000"/>
+                        </a:lnSpc>
+                        <a:buNone/>
+                      </a:pPr>
+                      <a:r>
+                        <a:rPr lang="ja-JP" sz="2000" kern="100">
+                          <a:effectLst/>
+                          <a:highlight>
+                            <a:srgbClr val="FFFFFF"/>
+                          </a:highlight>
+                        </a:rPr>
+                        <a:t>Khác nhau</a:t>
+                      </a:r>
+                      <a:endParaRPr lang="ja-JP" sz="1800" kern="100">
+                        <a:effectLst/>
+                        <a:highlight>
+                          <a:srgbClr val="FFFFFF"/>
+                        </a:highlight>
+                        <a:latin typeface="+mj-lt"/>
+                        <a:ea typeface="游明朝" panose="02020400000000000000" pitchFamily="18" charset="-128"/>
+                      </a:endParaRPr>
+                    </a:p>
+                  </a:txBody>
+                  <a:tcPr marL="68580" marR="68580" marT="0" marB="0"/>
+                </a:tc>
+                <a:tc>
+                  <a:txBody>
+                    <a:bodyPr/>
+                    <a:lstStyle/>
+                    <a:p>
+                      <a:pPr>
+                        <a:lnSpc>
+                          <a:spcPct val="115000"/>
+                        </a:lnSpc>
+                        <a:buNone/>
+                      </a:pPr>
+                      <a:r>
+                        <a:rPr lang="ja-JP" sz="2000" kern="100">
+                          <a:effectLst/>
+                          <a:highlight>
+                            <a:srgbClr val="FFFFFF"/>
+                          </a:highlight>
+                        </a:rPr>
+                        <a:t>Giống nhau</a:t>
+                      </a:r>
+                      <a:endParaRPr lang="ja-JP" sz="1800" kern="100">
+                        <a:effectLst/>
+                        <a:highlight>
+                          <a:srgbClr val="FFFFFF"/>
+                        </a:highlight>
+                        <a:latin typeface="+mj-lt"/>
+                        <a:ea typeface="游明朝" panose="02020400000000000000" pitchFamily="18" charset="-128"/>
+                      </a:endParaRPr>
+                    </a:p>
+                  </a:txBody>
+                  <a:tcPr marL="68580" marR="68580" marT="0" marB="0"/>
+                </a:tc>
+                <a:extLst>
+                  <a:ext uri="{0D108BD9-81ED-4DB2-BD59-A6C34878D82A}">
+                    <a16:rowId xmlns:a16="http://schemas.microsoft.com/office/drawing/2014/main" val="1917338762"/>
+                  </a:ext>
+                </a:extLst>
+              </a:tr>
+              <a:tr h="749300">
+                <a:tc>
+                  <a:txBody>
+                    <a:bodyPr/>
+                    <a:lstStyle/>
+                    <a:p>
+                      <a:pPr>
+                        <a:lnSpc>
+                          <a:spcPct val="115000"/>
+                        </a:lnSpc>
+                        <a:buNone/>
+                      </a:pPr>
+                      <a:r>
+                        <a:rPr lang="ja-JP" sz="2000" kern="100">
+                          <a:effectLst/>
+                          <a:highlight>
+                            <a:srgbClr val="FFFFFF"/>
+                          </a:highlight>
+                        </a:rPr>
+                        <a:t>Trả về  </a:t>
+                      </a:r>
+                      <a:endParaRPr lang="ja-JP" sz="1800" kern="100">
+                        <a:effectLst/>
+                        <a:highlight>
+                          <a:srgbClr val="FFFFFF"/>
+                        </a:highlight>
+                        <a:latin typeface="+mj-lt"/>
+                        <a:ea typeface="游明朝" panose="02020400000000000000" pitchFamily="18" charset="-128"/>
+                      </a:endParaRPr>
+                    </a:p>
+                  </a:txBody>
+                  <a:tcPr marL="68580" marR="68580" marT="0" marB="0"/>
+                </a:tc>
+                <a:tc>
+                  <a:txBody>
+                    <a:bodyPr/>
+                    <a:lstStyle/>
+                    <a:p>
+                      <a:pPr>
+                        <a:lnSpc>
+                          <a:spcPct val="115000"/>
+                        </a:lnSpc>
+                        <a:buNone/>
+                      </a:pPr>
+                      <a:r>
+                        <a:rPr lang="ja-JP" sz="2000" kern="100">
+                          <a:effectLst/>
+                          <a:highlight>
+                            <a:srgbClr val="FFFFFF"/>
+                          </a:highlight>
+                        </a:rPr>
+                        <a:t>Có thể khác nhau </a:t>
+                      </a:r>
+                      <a:endParaRPr lang="ja-JP" sz="1800" kern="100">
+                        <a:effectLst/>
+                        <a:highlight>
+                          <a:srgbClr val="FFFFFF"/>
+                        </a:highlight>
+                        <a:latin typeface="+mj-lt"/>
+                        <a:ea typeface="游明朝" panose="02020400000000000000" pitchFamily="18" charset="-128"/>
+                      </a:endParaRPr>
+                    </a:p>
+                  </a:txBody>
+                  <a:tcPr marL="68580" marR="68580" marT="0" marB="0"/>
+                </a:tc>
+                <a:tc>
+                  <a:txBody>
+                    <a:bodyPr/>
+                    <a:lstStyle/>
+                    <a:p>
+                      <a:pPr>
+                        <a:lnSpc>
+                          <a:spcPct val="115000"/>
+                        </a:lnSpc>
+                        <a:buNone/>
+                      </a:pPr>
+                      <a:r>
+                        <a:rPr lang="ja-JP" sz="2000" kern="100">
+                          <a:effectLst/>
+                          <a:highlight>
+                            <a:srgbClr val="FFFFFF"/>
+                          </a:highlight>
+                        </a:rPr>
+                        <a:t>Phải giống hoặc kiểu con</a:t>
+                      </a:r>
+                      <a:endParaRPr lang="ja-JP" sz="1800" kern="100">
+                        <a:effectLst/>
+                        <a:highlight>
+                          <a:srgbClr val="FFFFFF"/>
+                        </a:highlight>
+                        <a:latin typeface="+mj-lt"/>
+                        <a:ea typeface="游明朝" panose="02020400000000000000" pitchFamily="18" charset="-128"/>
+                      </a:endParaRPr>
+                    </a:p>
+                  </a:txBody>
+                  <a:tcPr marL="68580" marR="68580" marT="0" marB="0"/>
+                </a:tc>
+                <a:extLst>
+                  <a:ext uri="{0D108BD9-81ED-4DB2-BD59-A6C34878D82A}">
+                    <a16:rowId xmlns:a16="http://schemas.microsoft.com/office/drawing/2014/main" val="4083475965"/>
+                  </a:ext>
+                </a:extLst>
+              </a:tr>
+              <a:tr h="749300">
+                <a:tc>
+                  <a:txBody>
+                    <a:bodyPr/>
+                    <a:lstStyle/>
+                    <a:p>
+                      <a:pPr>
+                        <a:lnSpc>
+                          <a:spcPct val="115000"/>
+                        </a:lnSpc>
+                        <a:buNone/>
+                      </a:pPr>
+                      <a:r>
+                        <a:rPr lang="ja-JP" sz="2000" kern="100">
+                          <a:effectLst/>
+                          <a:highlight>
+                            <a:srgbClr val="FFFFFF"/>
+                          </a:highlight>
+                        </a:rPr>
+                        <a:t>Quyết định gọi lúc</a:t>
+                      </a:r>
+                      <a:endParaRPr lang="ja-JP" sz="1800" kern="100">
+                        <a:effectLst/>
+                        <a:highlight>
+                          <a:srgbClr val="FFFFFF"/>
+                        </a:highlight>
+                        <a:latin typeface="+mj-lt"/>
+                        <a:ea typeface="游明朝" panose="02020400000000000000" pitchFamily="18" charset="-128"/>
+                      </a:endParaRPr>
+                    </a:p>
+                  </a:txBody>
+                  <a:tcPr marL="68580" marR="68580" marT="0" marB="0"/>
+                </a:tc>
+                <a:tc>
+                  <a:txBody>
+                    <a:bodyPr/>
+                    <a:lstStyle/>
+                    <a:p>
+                      <a:pPr>
+                        <a:lnSpc>
+                          <a:spcPct val="115000"/>
+                        </a:lnSpc>
+                        <a:buNone/>
+                      </a:pPr>
+                      <a:r>
+                        <a:rPr lang="ja-JP" sz="2000" kern="100">
+                          <a:effectLst/>
+                          <a:highlight>
+                            <a:srgbClr val="FFFFFF"/>
+                          </a:highlight>
+                        </a:rPr>
+                        <a:t>Biên dịch (compile time)</a:t>
+                      </a:r>
+                      <a:endParaRPr lang="ja-JP" sz="1800" kern="100">
+                        <a:effectLst/>
+                        <a:highlight>
+                          <a:srgbClr val="FFFFFF"/>
+                        </a:highlight>
+                        <a:latin typeface="+mj-lt"/>
+                        <a:ea typeface="游明朝" panose="02020400000000000000" pitchFamily="18" charset="-128"/>
+                      </a:endParaRPr>
+                    </a:p>
+                  </a:txBody>
+                  <a:tcPr marL="68580" marR="68580" marT="0" marB="0"/>
+                </a:tc>
+                <a:tc>
+                  <a:txBody>
+                    <a:bodyPr/>
+                    <a:lstStyle/>
+                    <a:p>
+                      <a:pPr>
+                        <a:lnSpc>
+                          <a:spcPct val="115000"/>
+                        </a:lnSpc>
+                        <a:buNone/>
+                      </a:pPr>
+                      <a:r>
+                        <a:rPr lang="ja-JP" sz="2000" kern="100" dirty="0">
+                          <a:effectLst/>
+                          <a:highlight>
+                            <a:srgbClr val="FFFFFF"/>
+                          </a:highlight>
+                        </a:rPr>
+                        <a:t>Chạy (runtime)</a:t>
+                      </a:r>
+                      <a:endParaRPr lang="ja-JP" sz="1800" kern="100" dirty="0">
+                        <a:effectLst/>
+                        <a:highlight>
+                          <a:srgbClr val="FFFFFF"/>
+                        </a:highlight>
+                        <a:latin typeface="+mj-lt"/>
+                        <a:ea typeface="游明朝" panose="02020400000000000000" pitchFamily="18" charset="-128"/>
+                      </a:endParaRPr>
+                    </a:p>
+                  </a:txBody>
+                  <a:tcPr marL="68580" marR="68580" marT="0" marB="0"/>
+                </a:tc>
+                <a:extLst>
+                  <a:ext uri="{0D108BD9-81ED-4DB2-BD59-A6C34878D82A}">
+                    <a16:rowId xmlns:a16="http://schemas.microsoft.com/office/drawing/2014/main" val="1575604876"/>
+                  </a:ext>
+                </a:extLst>
+              </a:tr>
+            </a:tbl>
+          </a:graphicData>
+        </a:graphic>
+      </p:graphicFrame>
     </p:spTree>
     <p:extLst>
       <p:ext uri="{BB962C8B-B14F-4D97-AF65-F5344CB8AC3E}">

</xml_diff>